<commit_message>
Harold Round 10: presentation revisions (feedback edits v3)
Co-Authored-By: Claude Opus 4.7 (1M context) <noreply@anthropic.com>
</commit_message>
<xml_diff>
--- a/Harold's Presentation Revisions.pptx
+++ b/Harold's Presentation Revisions.pptx
@@ -21281,28 +21281,28 @@
         <p:spPr>
           <a:xfrm>
             <a:off x="1019175" y="6407051"/>
-            <a:ext cx="6550209" cy="1054894"/>
-          </a:xfrm>
-          <a:prstGeom prst="rect">
-            <a:avLst/>
-          </a:prstGeom>
-          <a:noFill/>
-          <a:ln/>
-        </p:spPr>
-        <p:txBody>
-          <a:bodyPr wrap="square" lIns="25400" tIns="25400" rIns="25400" bIns="25400" rtlCol="0" anchor="t">
-            <a:normAutofit/>
-          </a:bodyPr>
-          <a:lstStyle/>
-          <a:p>
-            <a:pPr algn="l" indent="0" marL="0">
-              <a:lnSpc>
-                <a:spcPct val="150000"/>
-              </a:lnSpc>
-              <a:buNone/>
-            </a:pPr>
-            <a:r>
-              <a:rPr lang="en-US" sz="1335" dirty="0">
+            <a:ext cx="6550209" cy="2800000"/>
+          </a:xfrm>
+          <a:prstGeom prst="rect">
+            <a:avLst/>
+          </a:prstGeom>
+          <a:noFill/>
+          <a:ln/>
+        </p:spPr>
+        <p:txBody>
+          <a:bodyPr wrap="square" lIns="25400" tIns="25400" rIns="25400" bIns="25400" rtlCol="0" anchor="t">
+            <a:normAutofit/>
+          </a:bodyPr>
+          <a:lstStyle/>
+          <a:p>
+            <a:pPr algn="l" indent="0" marL="0">
+              <a:lnSpc>
+                <a:spcPct val="140000"/>
+              </a:lnSpc>
+              <a:buNone/>
+            </a:pPr>
+            <a:r>
+              <a:rPr lang="en-US" sz="1200" dirty="0">
                 <a:solidFill>
                   <a:srgbClr val="2C313E"/>
                 </a:solidFill>
@@ -21310,16 +21310,10 @@
                 <a:ea typeface="Georgia" pitchFamily="34" charset="-122"/>
                 <a:cs typeface="Georgia" pitchFamily="34" charset="-120"/>
               </a:rPr>
-              <a:t>Attack distributions are </a:t>
-            </a:r>
-            <a:pPr algn="l" indent="0" marL="0">
-              <a:lnSpc>
-                <a:spcPct val="150000"/>
-              </a:lnSpc>
-              <a:buNone/>
-            </a:pPr>
-            <a:r>
-              <a:rPr lang="en-US" sz="1335" b="1" dirty="0">
+              <a:t>Attack flows are heavily </a:t>
+            </a:r>
+            <a:r>
+              <a:rPr lang="en-US" sz="1200" b="1" dirty="0">
                 <a:solidFill>
                   <a:srgbClr val="2C313E"/>
                 </a:solidFill>
@@ -21327,16 +21321,10 @@
                 <a:ea typeface="Georgia" pitchFamily="34" charset="-122"/>
                 <a:cs typeface="Georgia" pitchFamily="34" charset="-120"/>
               </a:rPr>
-              <a:t>bimodal </a:t>
-            </a:r>
-            <a:pPr algn="l" indent="0" marL="0">
-              <a:lnSpc>
-                <a:spcPct val="150000"/>
-              </a:lnSpc>
-              <a:buNone/>
-            </a:pPr>
-            <a:r>
-              <a:rPr lang="en-US" sz="1335" dirty="0">
+              <a:t>right-skewed</a:t>
+            </a:r>
+            <a:r>
+              <a:rPr lang="en-US" sz="1200" dirty="0">
                 <a:solidFill>
                   <a:srgbClr val="2C313E"/>
                 </a:solidFill>
@@ -21344,16 +21332,76 @@
                 <a:ea typeface="Georgia" pitchFamily="34" charset="-122"/>
                 <a:cs typeface="Georgia" pitchFamily="34" charset="-120"/>
               </a:rPr>
-              <a:t>: most flows cluster near zero, with a small subset reaching extreme right-tail values. For </a:t>
-            </a:r>
-            <a:pPr algn="l" indent="0" marL="0">
-              <a:lnSpc>
-                <a:spcPct val="150000"/>
-              </a:lnSpc>
-              <a:buNone/>
-            </a:pPr>
-            <a:r>
-              <a:rPr lang="en-US" sz="1335" dirty="0">
+              <a:t>: most cluster near zero, but a small subset reaches extreme tail values — see the </a:t>
+            </a:r>
+            <a:r>
+              <a:rPr lang="en-US" sz="1200" b="1" dirty="0">
+                <a:solidFill>
+                  <a:srgbClr val="2C313E"/>
+                </a:solidFill>
+                <a:latin typeface="Georgia" pitchFamily="34" charset="0"/>
+                <a:ea typeface="Georgia" pitchFamily="34" charset="-122"/>
+                <a:cs typeface="Georgia" pitchFamily="34" charset="-120"/>
+              </a:rPr>
+              <a:t>mean-vs-median gap</a:t>
+            </a:r>
+            <a:r>
+              <a:rPr lang="en-US" sz="1200" dirty="0">
+                <a:solidFill>
+                  <a:srgbClr val="2C313E"/>
+                </a:solidFill>
+                <a:latin typeface="Georgia" pitchFamily="34" charset="0"/>
+                <a:ea typeface="Georgia" pitchFamily="34" charset="-122"/>
+                <a:cs typeface="Georgia" pitchFamily="34" charset="-120"/>
+              </a:rPr>
+              <a:t> in the table (medians of </a:t>
+            </a:r>
+            <a:r>
+              <a:rPr lang="en-US" sz="1200" b="1" dirty="0">
+                <a:solidFill>
+                  <a:srgbClr val="2C313E"/>
+                </a:solidFill>
+                <a:latin typeface="Georgia" pitchFamily="34" charset="0"/>
+                <a:ea typeface="Georgia" pitchFamily="34" charset="-122"/>
+                <a:cs typeface="Georgia" pitchFamily="34" charset="-120"/>
+              </a:rPr>
+              <a:t>6 and 12</a:t>
+            </a:r>
+            <a:r>
+              <a:rPr lang="en-US" sz="1200" dirty="0">
+                <a:solidFill>
+                  <a:srgbClr val="2C313E"/>
+                </a:solidFill>
+                <a:latin typeface="Georgia" pitchFamily="34" charset="0"/>
+                <a:ea typeface="Georgia" pitchFamily="34" charset="-122"/>
+                <a:cs typeface="Georgia" pitchFamily="34" charset="-120"/>
+              </a:rPr>
+              <a:t> vs means of </a:t>
+            </a:r>
+            <a:r>
+              <a:rPr lang="en-US" sz="1200" b="1" dirty="0">
+                <a:solidFill>
+                  <a:srgbClr val="2C313E"/>
+                </a:solidFill>
+                <a:latin typeface="Georgia" pitchFamily="34" charset="0"/>
+                <a:ea typeface="Georgia" pitchFamily="34" charset="-122"/>
+                <a:cs typeface="Georgia" pitchFamily="34" charset="-120"/>
+              </a:rPr>
+              <a:t>854 and 2.3M</a:t>
+            </a:r>
+            <a:r>
+              <a:rPr lang="en-US" sz="1200" dirty="0">
+                <a:solidFill>
+                  <a:srgbClr val="2C313E"/>
+                </a:solidFill>
+                <a:latin typeface="Georgia" pitchFamily="34" charset="0"/>
+                <a:ea typeface="Georgia" pitchFamily="34" charset="-122"/>
+                <a:cs typeface="Georgia" pitchFamily="34" charset="-120"/>
+              </a:rPr>
+              <a:t>). For </a:t>
+            </a:r>
+            <a:r>
+              <a:rPr lang="en-US" sz="1200" dirty="0">
                 <a:solidFill>
                   <a:srgbClr val="2C313E"/>
                 </a:solidFill>
@@ -21361,16 +21409,10 @@
                 <a:ea typeface="Courier New" pitchFamily="34" charset="-122"/>
                 <a:cs typeface="Courier New" pitchFamily="34" charset="-120"/>
               </a:rPr>
-              <a:t>Destination.Port </a:t>
-            </a:r>
-            <a:pPr algn="l" indent="0" marL="0">
-              <a:lnSpc>
-                <a:spcPct val="150000"/>
-              </a:lnSpc>
-              <a:buNone/>
-            </a:pPr>
-            <a:r>
-              <a:rPr lang="en-US" sz="1335" dirty="0">
+              <a:t>Destination.Port</a:t>
+            </a:r>
+            <a:r>
+              <a:rPr lang="en-US" sz="1200" dirty="0">
                 <a:solidFill>
                   <a:srgbClr val="2C313E"/>
                 </a:solidFill>
@@ -21378,16 +21420,10 @@
                 <a:ea typeface="Georgia" pitchFamily="34" charset="-122"/>
                 <a:cs typeface="Georgia" pitchFamily="34" charset="-120"/>
               </a:rPr>
-              <a:t>the </a:t>
-            </a:r>
-            <a:pPr algn="l" indent="0" marL="0">
-              <a:lnSpc>
-                <a:spcPct val="150000"/>
-              </a:lnSpc>
-              <a:buNone/>
-            </a:pPr>
-            <a:r>
-              <a:rPr lang="en-US" sz="1335" b="1" dirty="0">
+              <a:t>, this also produces a visible </a:t>
+            </a:r>
+            <a:r>
+              <a:rPr lang="en-US" sz="1200" b="1" dirty="0">
                 <a:solidFill>
                   <a:srgbClr val="1E3A5F"/>
                 </a:solidFill>
@@ -21395,16 +21431,10 @@
                 <a:ea typeface="Georgia" pitchFamily="34" charset="-122"/>
                 <a:cs typeface="Georgia" pitchFamily="34" charset="-120"/>
               </a:rPr>
-              <a:t>benign </a:t>
-            </a:r>
-            <a:pPr algn="l" indent="0" marL="0">
-              <a:lnSpc>
-                <a:spcPct val="150000"/>
-              </a:lnSpc>
-              <a:buNone/>
-            </a:pPr>
-            <a:r>
-              <a:rPr lang="en-US" sz="1335" dirty="0">
+              <a:t>second mode</a:t>
+            </a:r>
+            <a:r>
+              <a:rPr lang="en-US" sz="1200" dirty="0">
                 <a:solidFill>
                   <a:srgbClr val="2C313E"/>
                 </a:solidFill>
@@ -21412,111 +21442,9 @@
                 <a:ea typeface="Georgia" pitchFamily="34" charset="-122"/>
                 <a:cs typeface="Georgia" pitchFamily="34" charset="-120"/>
               </a:rPr>
-              <a:t>tail is actually heavier than the </a:t>
-            </a:r>
-            <a:pPr algn="l" indent="0" marL="0">
-              <a:lnSpc>
-                <a:spcPct val="150000"/>
-              </a:lnSpc>
-              <a:buNone/>
-            </a:pPr>
-            <a:r>
-              <a:rPr lang="en-US" sz="1335" b="1" dirty="0">
-                <a:solidFill>
-                  <a:srgbClr val="B33A2E"/>
-                </a:solidFill>
-                <a:latin typeface="Georgia" pitchFamily="34" charset="0"/>
-                <a:ea typeface="Georgia" pitchFamily="34" charset="-122"/>
-                <a:cs typeface="Georgia" pitchFamily="34" charset="-120"/>
-              </a:rPr>
-              <a:t>attack </a:t>
-            </a:r>
-            <a:pPr algn="l" indent="0" marL="0">
-              <a:lnSpc>
-                <a:spcPct val="150000"/>
-              </a:lnSpc>
-              <a:buNone/>
-            </a:pPr>
-            <a:r>
-              <a:rPr lang="en-US" sz="1335" dirty="0">
-                <a:solidFill>
-                  <a:srgbClr val="2C313E"/>
-                </a:solidFill>
-                <a:latin typeface="Georgia" pitchFamily="34" charset="0"/>
-                <a:ea typeface="Georgia" pitchFamily="34" charset="-122"/>
-                <a:cs typeface="Georgia" pitchFamily="34" charset="-120"/>
-              </a:rPr>
-              <a:t>tail — benign 99th percentile = </a:t>
-            </a:r>
-            <a:pPr algn="l" indent="0" marL="0">
-              <a:lnSpc>
-                <a:spcPct val="150000"/>
-              </a:lnSpc>
-              <a:buNone/>
-            </a:pPr>
-            <a:r>
-              <a:rPr lang="en-US" sz="1335" b="1" dirty="0">
-                <a:solidFill>
-                  <a:srgbClr val="2C313E"/>
-                </a:solidFill>
-                <a:latin typeface="Georgia" pitchFamily="34" charset="0"/>
-                <a:ea typeface="Georgia" pitchFamily="34" charset="-122"/>
-                <a:cs typeface="Georgia" pitchFamily="34" charset="-120"/>
-              </a:rPr>
-              <a:t>61,502 </a:t>
-            </a:r>
-            <a:pPr algn="l" indent="0" marL="0">
-              <a:lnSpc>
-                <a:spcPct val="150000"/>
-              </a:lnSpc>
-              <a:buNone/>
-            </a:pPr>
-            <a:r>
-              <a:rPr lang="en-US" sz="1335" dirty="0">
-                <a:solidFill>
-                  <a:srgbClr val="2C313E"/>
-                </a:solidFill>
-                <a:latin typeface="Georgia" pitchFamily="34" charset="0"/>
-                <a:ea typeface="Georgia" pitchFamily="34" charset="-122"/>
-                <a:cs typeface="Georgia" pitchFamily="34" charset="-120"/>
-              </a:rPr>
-              <a:t>, attack 99th percentile = </a:t>
-            </a:r>
-            <a:pPr algn="l" indent="0" marL="0">
-              <a:lnSpc>
-                <a:spcPct val="150000"/>
-              </a:lnSpc>
-              <a:buNone/>
-            </a:pPr>
-            <a:r>
-              <a:rPr lang="en-US" sz="1335" b="1" dirty="0">
-                <a:solidFill>
-                  <a:srgbClr val="2C313E"/>
-                </a:solidFill>
-                <a:latin typeface="Georgia" pitchFamily="34" charset="0"/>
-                <a:ea typeface="Georgia" pitchFamily="34" charset="-122"/>
-                <a:cs typeface="Georgia" pitchFamily="34" charset="-120"/>
-              </a:rPr>
-              <a:t>50,047</a:t>
-            </a:r>
-            <a:pPr algn="l" indent="0" marL="0">
-              <a:lnSpc>
-                <a:spcPct val="150000"/>
-              </a:lnSpc>
-              <a:buNone/>
-            </a:pPr>
-            <a:r>
-              <a:rPr lang="en-US" sz="1335" dirty="0">
-                <a:solidFill>
-                  <a:srgbClr val="2C313E"/>
-                </a:solidFill>
-                <a:latin typeface="Georgia" pitchFamily="34" charset="0"/>
-                <a:ea typeface="Georgia" pitchFamily="34" charset="-122"/>
-                <a:cs typeface="Georgia" pitchFamily="34" charset="-120"/>
-              </a:rPr>
-              <a:t>.</a:t>
-            </a:r>
-            <a:endParaRPr lang="en-US" sz="1335" dirty="0"/>
+              <a:t> around the dynamic-port range; the bimodality is less visible in the other two because the extreme values are too rare and too spread out to register on a linear density plot.</a:t>
+            </a:r>
+            <a:endParaRPr lang="en-US" sz="1200" dirty="0"/>
           </a:p>
         </p:txBody>
       </p:sp>

</xml_diff>